<commit_message>
added toolbar option to visualize previous profile within 12 hours
</commit_message>
<xml_diff>
--- a/resources/icons.pptx
+++ b/resources/icons.pptx
@@ -5,12 +5,13 @@
     <p:sldMasterId id="2147483672" r:id="rId1"/>
   </p:sldMasterIdLst>
   <p:notesMasterIdLst>
-    <p:notesMasterId r:id="rId5"/>
+    <p:notesMasterId r:id="rId6"/>
   </p:notesMasterIdLst>
   <p:sldIdLst>
     <p:sldId id="388" r:id="rId2"/>
     <p:sldId id="574" r:id="rId3"/>
     <p:sldId id="575" r:id="rId4"/>
+    <p:sldId id="576" r:id="rId5"/>
   </p:sldIdLst>
   <p:sldSz cx="5486400" cy="5486400"/>
   <p:notesSz cx="6858000" cy="9144000"/>
@@ -199,7 +200,7 @@
           <a:p>
             <a:fld id="{173FD435-C119-4590-9D53-7CAF83F19020}" type="datetimeFigureOut">
               <a:rPr lang="en-US" smtClean="0"/>
-              <a:t>4/4/2021</a:t>
+              <a:t>5/11/2026</a:t>
             </a:fld>
             <a:endParaRPr lang="en-US"/>
           </a:p>
@@ -597,7 +598,7 @@
           <a:p>
             <a:fld id="{D296FE55-24A0-4405-87BA-F203EB2AA989}" type="datetimeFigureOut">
               <a:rPr lang="en-US" smtClean="0"/>
-              <a:t>4/4/2021</a:t>
+              <a:t>5/11/2026</a:t>
             </a:fld>
             <a:endParaRPr lang="en-US"/>
           </a:p>
@@ -767,7 +768,7 @@
           <a:p>
             <a:fld id="{D296FE55-24A0-4405-87BA-F203EB2AA989}" type="datetimeFigureOut">
               <a:rPr lang="en-US" smtClean="0"/>
-              <a:t>4/4/2021</a:t>
+              <a:t>5/11/2026</a:t>
             </a:fld>
             <a:endParaRPr lang="en-US"/>
           </a:p>
@@ -947,7 +948,7 @@
           <a:p>
             <a:fld id="{D296FE55-24A0-4405-87BA-F203EB2AA989}" type="datetimeFigureOut">
               <a:rPr lang="en-US" smtClean="0"/>
-              <a:t>4/4/2021</a:t>
+              <a:t>5/11/2026</a:t>
             </a:fld>
             <a:endParaRPr lang="en-US"/>
           </a:p>
@@ -1117,7 +1118,7 @@
           <a:p>
             <a:fld id="{D296FE55-24A0-4405-87BA-F203EB2AA989}" type="datetimeFigureOut">
               <a:rPr lang="en-US" smtClean="0"/>
-              <a:t>4/4/2021</a:t>
+              <a:t>5/11/2026</a:t>
             </a:fld>
             <a:endParaRPr lang="en-US"/>
           </a:p>
@@ -1361,7 +1362,7 @@
           <a:p>
             <a:fld id="{D296FE55-24A0-4405-87BA-F203EB2AA989}" type="datetimeFigureOut">
               <a:rPr lang="en-US" smtClean="0"/>
-              <a:t>4/4/2021</a:t>
+              <a:t>5/11/2026</a:t>
             </a:fld>
             <a:endParaRPr lang="en-US"/>
           </a:p>
@@ -1593,7 +1594,7 @@
           <a:p>
             <a:fld id="{D296FE55-24A0-4405-87BA-F203EB2AA989}" type="datetimeFigureOut">
               <a:rPr lang="en-US" smtClean="0"/>
-              <a:t>4/4/2021</a:t>
+              <a:t>5/11/2026</a:t>
             </a:fld>
             <a:endParaRPr lang="en-US"/>
           </a:p>
@@ -1960,7 +1961,7 @@
           <a:p>
             <a:fld id="{D296FE55-24A0-4405-87BA-F203EB2AA989}" type="datetimeFigureOut">
               <a:rPr lang="en-US" smtClean="0"/>
-              <a:t>4/4/2021</a:t>
+              <a:t>5/11/2026</a:t>
             </a:fld>
             <a:endParaRPr lang="en-US"/>
           </a:p>
@@ -2078,7 +2079,7 @@
           <a:p>
             <a:fld id="{D296FE55-24A0-4405-87BA-F203EB2AA989}" type="datetimeFigureOut">
               <a:rPr lang="en-US" smtClean="0"/>
-              <a:t>4/4/2021</a:t>
+              <a:t>5/11/2026</a:t>
             </a:fld>
             <a:endParaRPr lang="en-US"/>
           </a:p>
@@ -2173,7 +2174,7 @@
           <a:p>
             <a:fld id="{D296FE55-24A0-4405-87BA-F203EB2AA989}" type="datetimeFigureOut">
               <a:rPr lang="en-US" smtClean="0"/>
-              <a:t>4/4/2021</a:t>
+              <a:t>5/11/2026</a:t>
             </a:fld>
             <a:endParaRPr lang="en-US"/>
           </a:p>
@@ -2450,7 +2451,7 @@
           <a:p>
             <a:fld id="{D296FE55-24A0-4405-87BA-F203EB2AA989}" type="datetimeFigureOut">
               <a:rPr lang="en-US" smtClean="0"/>
-              <a:t>4/4/2021</a:t>
+              <a:t>5/11/2026</a:t>
             </a:fld>
             <a:endParaRPr lang="en-US"/>
           </a:p>
@@ -2707,7 +2708,7 @@
           <a:p>
             <a:fld id="{D296FE55-24A0-4405-87BA-F203EB2AA989}" type="datetimeFigureOut">
               <a:rPr lang="en-US" smtClean="0"/>
-              <a:t>4/4/2021</a:t>
+              <a:t>5/11/2026</a:t>
             </a:fld>
             <a:endParaRPr lang="en-US"/>
           </a:p>
@@ -2920,7 +2921,7 @@
           <a:p>
             <a:fld id="{D296FE55-24A0-4405-87BA-F203EB2AA989}" type="datetimeFigureOut">
               <a:rPr lang="en-US" smtClean="0"/>
-              <a:t>4/4/2021</a:t>
+              <a:t>5/11/2026</a:t>
             </a:fld>
             <a:endParaRPr lang="en-US"/>
           </a:p>
@@ -3594,7 +3595,7 @@
           <a:p>
             <a:pPr algn="ctr"/>
             <a:r>
-              <a:rPr lang="en-US" sz="16600" b="1" cap="none" spc="0" dirty="0" smtClean="0">
+              <a:rPr lang="en-US" sz="16600" b="1" cap="none" spc="0" dirty="0">
                 <a:ln/>
                 <a:solidFill>
                   <a:schemeClr val="accent2">
@@ -3644,7 +3645,7 @@
           <a:p>
             <a:pPr algn="ctr"/>
             <a:r>
-              <a:rPr lang="en-US" sz="16600" b="1" cap="none" spc="0" dirty="0" smtClean="0">
+              <a:rPr lang="en-US" sz="16600" b="1" cap="none" spc="0" dirty="0">
                 <a:ln/>
                 <a:solidFill>
                   <a:schemeClr val="accent1">
@@ -3655,15 +3656,6 @@
               </a:rPr>
               <a:t>SIS</a:t>
             </a:r>
-            <a:endParaRPr lang="en-US" sz="16600" b="1" cap="none" spc="0" dirty="0">
-              <a:ln/>
-              <a:solidFill>
-                <a:schemeClr val="accent1">
-                  <a:lumMod val="75000"/>
-                </a:schemeClr>
-              </a:solidFill>
-              <a:effectLst/>
-            </a:endParaRPr>
           </a:p>
         </p:txBody>
       </p:sp>
@@ -3714,6 +3706,346 @@
     <p:extLst>
       <p:ext uri="{BB962C8B-B14F-4D97-AF65-F5344CB8AC3E}">
         <p14:creationId xmlns:p14="http://schemas.microsoft.com/office/powerpoint/2010/main" val="2490228557"/>
+      </p:ext>
+    </p:extLst>
+  </p:cSld>
+  <p:clrMapOvr>
+    <a:masterClrMapping/>
+  </p:clrMapOvr>
+</p:sld>
+</file>
+
+<file path=ppt/slides/slide4.xml><?xml version="1.0" encoding="utf-8"?>
+<p:sld xmlns:a="http://schemas.openxmlformats.org/drawingml/2006/main" xmlns:r="http://schemas.openxmlformats.org/officeDocument/2006/relationships" xmlns:p="http://schemas.openxmlformats.org/presentationml/2006/main">
+  <p:cSld>
+    <p:spTree>
+      <p:nvGrpSpPr>
+        <p:cNvPr id="1" name=""/>
+        <p:cNvGrpSpPr/>
+        <p:nvPr/>
+      </p:nvGrpSpPr>
+      <p:grpSpPr>
+        <a:xfrm>
+          <a:off x="0" y="0"/>
+          <a:ext cx="0" cy="0"/>
+          <a:chOff x="0" y="0"/>
+          <a:chExt cx="0" cy="0"/>
+        </a:xfrm>
+      </p:grpSpPr>
+      <p:sp>
+        <p:nvSpPr>
+          <p:cNvPr id="4" name="Freeform: Shape 3">
+            <a:extLst>
+              <a:ext uri="{FF2B5EF4-FFF2-40B4-BE49-F238E27FC236}">
+                <a16:creationId xmlns:a16="http://schemas.microsoft.com/office/drawing/2014/main" id="{942F6478-FAF1-E572-AF09-CFCFFA5B4BF9}"/>
+              </a:ext>
+            </a:extLst>
+          </p:cNvPr>
+          <p:cNvSpPr/>
+          <p:nvPr/>
+        </p:nvSpPr>
+        <p:spPr>
+          <a:xfrm>
+            <a:off x="3707297" y="606287"/>
+            <a:ext cx="1212574" cy="4472610"/>
+          </a:xfrm>
+          <a:custGeom>
+            <a:avLst/>
+            <a:gdLst>
+              <a:gd name="csX0" fmla="*/ 2277394 w 2277394"/>
+              <a:gd name="csY0" fmla="*/ 0 h 4979504"/>
+              <a:gd name="csX1" fmla="*/ 597681 w 2277394"/>
+              <a:gd name="csY1" fmla="*/ 815009 h 4979504"/>
+              <a:gd name="csX2" fmla="*/ 41089 w 2277394"/>
+              <a:gd name="csY2" fmla="*/ 2007704 h 4979504"/>
+              <a:gd name="csX3" fmla="*/ 1571715 w 2277394"/>
+              <a:gd name="csY3" fmla="*/ 3528391 h 4979504"/>
+              <a:gd name="csX4" fmla="*/ 2158124 w 2277394"/>
+              <a:gd name="csY4" fmla="*/ 4979504 h 4979504"/>
+              <a:gd name="csX5" fmla="*/ 2158124 w 2277394"/>
+              <a:gd name="csY5" fmla="*/ 4979504 h 4979504"/>
+            </a:gdLst>
+            <a:ahLst/>
+            <a:cxnLst>
+              <a:cxn ang="0">
+                <a:pos x="csX0" y="csY0"/>
+              </a:cxn>
+              <a:cxn ang="0">
+                <a:pos x="csX1" y="csY1"/>
+              </a:cxn>
+              <a:cxn ang="0">
+                <a:pos x="csX2" y="csY2"/>
+              </a:cxn>
+              <a:cxn ang="0">
+                <a:pos x="csX3" y="csY3"/>
+              </a:cxn>
+              <a:cxn ang="0">
+                <a:pos x="csX4" y="csY4"/>
+              </a:cxn>
+              <a:cxn ang="0">
+                <a:pos x="csX5" y="csY5"/>
+              </a:cxn>
+            </a:cxnLst>
+            <a:rect l="l" t="t" r="r" b="b"/>
+            <a:pathLst>
+              <a:path w="2277394" h="4979504">
+                <a:moveTo>
+                  <a:pt x="2277394" y="0"/>
+                </a:moveTo>
+                <a:cubicBezTo>
+                  <a:pt x="1623896" y="240196"/>
+                  <a:pt x="970398" y="480392"/>
+                  <a:pt x="597681" y="815009"/>
+                </a:cubicBezTo>
+                <a:cubicBezTo>
+                  <a:pt x="224964" y="1149626"/>
+                  <a:pt x="-121250" y="1555474"/>
+                  <a:pt x="41089" y="2007704"/>
+                </a:cubicBezTo>
+                <a:cubicBezTo>
+                  <a:pt x="203428" y="2459934"/>
+                  <a:pt x="1218876" y="3033091"/>
+                  <a:pt x="1571715" y="3528391"/>
+                </a:cubicBezTo>
+                <a:cubicBezTo>
+                  <a:pt x="1924554" y="4023691"/>
+                  <a:pt x="2158124" y="4979504"/>
+                  <a:pt x="2158124" y="4979504"/>
+                </a:cubicBezTo>
+                <a:lnTo>
+                  <a:pt x="2158124" y="4979504"/>
+                </a:lnTo>
+              </a:path>
+            </a:pathLst>
+          </a:custGeom>
+          <a:noFill/>
+          <a:ln w="127000">
+            <a:gradFill flip="none" rotWithShape="1">
+              <a:gsLst>
+                <a:gs pos="0">
+                  <a:srgbClr val="FFC000"/>
+                </a:gs>
+                <a:gs pos="75000">
+                  <a:schemeClr val="accent3">
+                    <a:lumMod val="95000"/>
+                    <a:lumOff val="5000"/>
+                  </a:schemeClr>
+                </a:gs>
+                <a:gs pos="100000">
+                  <a:schemeClr val="accent3">
+                    <a:lumMod val="60000"/>
+                  </a:schemeClr>
+                </a:gs>
+              </a:gsLst>
+              <a:path path="circle">
+                <a:fillToRect l="50000" t="130000" r="50000" b="-30000"/>
+              </a:path>
+              <a:tileRect/>
+            </a:gradFill>
+          </a:ln>
+        </p:spPr>
+        <p:style>
+          <a:lnRef idx="2">
+            <a:schemeClr val="accent1">
+              <a:shade val="15000"/>
+            </a:schemeClr>
+          </a:lnRef>
+          <a:fillRef idx="1">
+            <a:schemeClr val="accent1"/>
+          </a:fillRef>
+          <a:effectRef idx="0">
+            <a:schemeClr val="accent1"/>
+          </a:effectRef>
+          <a:fontRef idx="minor">
+            <a:schemeClr val="lt1"/>
+          </a:fontRef>
+        </p:style>
+        <p:txBody>
+          <a:bodyPr rtlCol="0" anchor="ctr"/>
+          <a:lstStyle/>
+          <a:p>
+            <a:pPr algn="ctr"/>
+            <a:endParaRPr lang="da-DK"/>
+          </a:p>
+        </p:txBody>
+      </p:sp>
+      <p:sp>
+        <p:nvSpPr>
+          <p:cNvPr id="5" name="Freeform: Shape 4">
+            <a:extLst>
+              <a:ext uri="{FF2B5EF4-FFF2-40B4-BE49-F238E27FC236}">
+                <a16:creationId xmlns:a16="http://schemas.microsoft.com/office/drawing/2014/main" id="{D1B74BF0-4886-5DDC-2314-1BCCB30397BE}"/>
+              </a:ext>
+            </a:extLst>
+          </p:cNvPr>
+          <p:cNvSpPr/>
+          <p:nvPr/>
+        </p:nvSpPr>
+        <p:spPr>
+          <a:xfrm>
+            <a:off x="566530" y="606287"/>
+            <a:ext cx="1659836" cy="4472610"/>
+          </a:xfrm>
+          <a:custGeom>
+            <a:avLst/>
+            <a:gdLst>
+              <a:gd name="csX0" fmla="*/ 2277394 w 2277394"/>
+              <a:gd name="csY0" fmla="*/ 0 h 4979504"/>
+              <a:gd name="csX1" fmla="*/ 597681 w 2277394"/>
+              <a:gd name="csY1" fmla="*/ 815009 h 4979504"/>
+              <a:gd name="csX2" fmla="*/ 41089 w 2277394"/>
+              <a:gd name="csY2" fmla="*/ 2007704 h 4979504"/>
+              <a:gd name="csX3" fmla="*/ 1571715 w 2277394"/>
+              <a:gd name="csY3" fmla="*/ 3528391 h 4979504"/>
+              <a:gd name="csX4" fmla="*/ 2158124 w 2277394"/>
+              <a:gd name="csY4" fmla="*/ 4979504 h 4979504"/>
+              <a:gd name="csX5" fmla="*/ 2158124 w 2277394"/>
+              <a:gd name="csY5" fmla="*/ 4979504 h 4979504"/>
+            </a:gdLst>
+            <a:ahLst/>
+            <a:cxnLst>
+              <a:cxn ang="0">
+                <a:pos x="csX0" y="csY0"/>
+              </a:cxn>
+              <a:cxn ang="0">
+                <a:pos x="csX1" y="csY1"/>
+              </a:cxn>
+              <a:cxn ang="0">
+                <a:pos x="csX2" y="csY2"/>
+              </a:cxn>
+              <a:cxn ang="0">
+                <a:pos x="csX3" y="csY3"/>
+              </a:cxn>
+              <a:cxn ang="0">
+                <a:pos x="csX4" y="csY4"/>
+              </a:cxn>
+              <a:cxn ang="0">
+                <a:pos x="csX5" y="csY5"/>
+              </a:cxn>
+            </a:cxnLst>
+            <a:rect l="l" t="t" r="r" b="b"/>
+            <a:pathLst>
+              <a:path w="2277394" h="4979504">
+                <a:moveTo>
+                  <a:pt x="2277394" y="0"/>
+                </a:moveTo>
+                <a:cubicBezTo>
+                  <a:pt x="1623896" y="240196"/>
+                  <a:pt x="970398" y="480392"/>
+                  <a:pt x="597681" y="815009"/>
+                </a:cubicBezTo>
+                <a:cubicBezTo>
+                  <a:pt x="224964" y="1149626"/>
+                  <a:pt x="-121250" y="1555474"/>
+                  <a:pt x="41089" y="2007704"/>
+                </a:cubicBezTo>
+                <a:cubicBezTo>
+                  <a:pt x="203428" y="2459934"/>
+                  <a:pt x="1218876" y="3033091"/>
+                  <a:pt x="1571715" y="3528391"/>
+                </a:cubicBezTo>
+                <a:cubicBezTo>
+                  <a:pt x="1924554" y="4023691"/>
+                  <a:pt x="2158124" y="4979504"/>
+                  <a:pt x="2158124" y="4979504"/>
+                </a:cubicBezTo>
+                <a:lnTo>
+                  <a:pt x="2158124" y="4979504"/>
+                </a:lnTo>
+              </a:path>
+            </a:pathLst>
+          </a:custGeom>
+          <a:noFill/>
+          <a:ln w="127000">
+            <a:gradFill flip="none" rotWithShape="1">
+              <a:gsLst>
+                <a:gs pos="0">
+                  <a:srgbClr val="FFC000"/>
+                </a:gs>
+                <a:gs pos="75000">
+                  <a:schemeClr val="accent3">
+                    <a:lumMod val="95000"/>
+                    <a:lumOff val="5000"/>
+                  </a:schemeClr>
+                </a:gs>
+                <a:gs pos="100000">
+                  <a:schemeClr val="accent3">
+                    <a:lumMod val="60000"/>
+                  </a:schemeClr>
+                </a:gs>
+              </a:gsLst>
+              <a:path path="circle">
+                <a:fillToRect l="50000" t="130000" r="50000" b="-30000"/>
+              </a:path>
+              <a:tileRect/>
+            </a:gradFill>
+          </a:ln>
+        </p:spPr>
+        <p:style>
+          <a:lnRef idx="2">
+            <a:schemeClr val="accent1">
+              <a:shade val="15000"/>
+            </a:schemeClr>
+          </a:lnRef>
+          <a:fillRef idx="1">
+            <a:schemeClr val="accent1"/>
+          </a:fillRef>
+          <a:effectRef idx="0">
+            <a:schemeClr val="accent1"/>
+          </a:effectRef>
+          <a:fontRef idx="minor">
+            <a:schemeClr val="lt1"/>
+          </a:fontRef>
+        </p:style>
+        <p:txBody>
+          <a:bodyPr rtlCol="0" anchor="ctr"/>
+          <a:lstStyle/>
+          <a:p>
+            <a:pPr algn="ctr"/>
+            <a:endParaRPr lang="da-DK"/>
+          </a:p>
+        </p:txBody>
+      </p:sp>
+      <p:pic>
+        <p:nvPicPr>
+          <p:cNvPr id="3" name="Graphic 2" descr="Hourglass 90% with solid fill">
+            <a:extLst>
+              <a:ext uri="{FF2B5EF4-FFF2-40B4-BE49-F238E27FC236}">
+                <a16:creationId xmlns:a16="http://schemas.microsoft.com/office/drawing/2014/main" id="{CC6116D4-4381-7856-D77D-DD5D3E521471}"/>
+              </a:ext>
+            </a:extLst>
+          </p:cNvPr>
+          <p:cNvPicPr>
+            <a:picLocks noChangeAspect="1"/>
+          </p:cNvPicPr>
+          <p:nvPr/>
+        </p:nvPicPr>
+        <p:blipFill>
+          <a:blip>
+            <a:extLst>
+              <a:ext uri="{96DAC541-7B7A-43D3-8B79-37D633B846F1}">
+                <asvg:svgBlip xmlns:asvg="http://schemas.microsoft.com/office/drawing/2016/SVG/main" r:embed="rId2"/>
+              </a:ext>
+            </a:extLst>
+          </a:blip>
+          <a:stretch>
+            <a:fillRect/>
+          </a:stretch>
+        </p:blipFill>
+        <p:spPr>
+          <a:xfrm>
+            <a:off x="1490870" y="1490870"/>
+            <a:ext cx="2504661" cy="2504661"/>
+          </a:xfrm>
+          <a:prstGeom prst="rect">
+            <a:avLst/>
+          </a:prstGeom>
+        </p:spPr>
+      </p:pic>
+    </p:spTree>
+    <p:extLst>
+      <p:ext uri="{BB962C8B-B14F-4D97-AF65-F5344CB8AC3E}">
+        <p14:creationId xmlns:p14="http://schemas.microsoft.com/office/powerpoint/2010/main" val="3483282405"/>
       </p:ext>
     </p:extLst>
   </p:cSld>

</xml_diff>